<commit_message>
Add calculator walkthrough and v1 release assets
Co-authored-by: Copilot <223556219+Copilot@users.noreply.github.com>
</commit_message>
<xml_diff>
--- a/enablement/business-case-calculator-overview.pptx
+++ b/enablement/business-case-calculator-overview.pptx
@@ -2254,7 +2254,7 @@
                 <a:ea typeface="Segoe UI" pitchFamily="34" charset="-122"/>
                 <a:cs typeface="Segoe UI" pitchFamily="34" charset="-120"/>
               </a:rPr>
-              <a:t>5 connected worksheets</a:t>
+              <a:t>6 connected worksheets</a:t>
             </a:r>
             <a:endParaRPr lang="en-US" sz="1050" dirty="0"/>
           </a:p>
@@ -2293,7 +2293,7 @@
                 <a:ea typeface="Segoe UI" pitchFamily="34" charset="-122"/>
                 <a:cs typeface="Segoe UI" pitchFamily="34" charset="-120"/>
               </a:rPr>
-              <a:t>Inputs | SQL TCO | Fabric SKUs | Workloads | Summary</a:t>
+              <a:t>Inputs | SQL TCO | Fabric | Workloads | Sensitivity | Summary</a:t>
             </a:r>
             <a:endParaRPr lang="en-US" sz="950" dirty="0"/>
           </a:p>

</xml_diff>